<commit_message>
build: generar PowerPoint auditado Del acero al algoritmo
</commit_message>
<xml_diff>
--- a/presentacion/Del_Acero_al_Algoritmo_FINAL_MORPH.pptx
+++ b/presentacion/Del_Acero_al_Algoritmo_FINAL_MORPH.pptx
@@ -25776,7 +25776,7 @@
                 </a:solidFill>
                 <a:latin typeface="Aptos"/>
               </a:rPr>
-              <a:t>RIC</a:t>
+              <a:t>CUARTILES</a:t>
             </a:r>
           </a:p>
         </p:txBody>
@@ -25811,7 +25811,7 @@
                 </a:solidFill>
                 <a:latin typeface="Aptos"/>
               </a:rPr>
-              <a:t>Q3 − Q1</a:t>
+              <a:t>Q1 / Q3</a:t>
             </a:r>
           </a:p>
         </p:txBody>
@@ -25846,7 +25846,7 @@
                 </a:solidFill>
                 <a:latin typeface="Aptos"/>
               </a:rPr>
-              <a:t>rango central</a:t>
+              <a:t>percentiles</a:t>
             </a:r>
           </a:p>
         </p:txBody>
@@ -25926,7 +25926,7 @@
                 </a:solidFill>
                 <a:latin typeface="Aptos"/>
               </a:rPr>
-              <a:t>El notebook contiene fi, hi, acumuladas, moda, percentiles, rango, varianza, desviación, CV y RIC.</a:t>
+              <a:t>El notebook aplica fi, hi, acumuladas, moda, percentiles, rango, desviación y CV; el RIC se reserva para la Pregunta 3.</a:t>
             </a:r>
           </a:p>
         </p:txBody>

</xml_diff>